<commit_message>
fix(deck): add guide, sync Table II with benchmark, fix section numbering
- Title slide: add 'Guide: Dr. Manikandan K, Professor Grade 2, Dept. of
  Database Systems, SCSE' (required by Assessment 9 QP)
- Table II: align with eval/output/table_ii.json - Gradient Boosting is the
  selected model (ROC-AUC 0.976), SVM is calibrated (0.949); deck previously
  reported an older run (SVM 0.969)
- Prose + speaker notes updated to the same run
- Record count 19,317 -> 13,980 (the value the committed dataset actually yields)
- Label overview slides '02 - Overview' to close the 01 -> 03 numbering gap
</commit_message>
<xml_diff>
--- a/project-final.pptx
+++ b/project-final.pptx
@@ -952,7 +952,7 @@
           <a:lstStyle/>
           <a:p>
             <a:r>
-              <a:t>Show that validation is real: bad payloads get HTTP 422. In the verified run, 19,317 records were ingested with 0 rejected.</a:t>
+              <a:t>Show that validation is real: bad payloads get HTTP 422. In the verified run, 13,980 records were ingested with 0 rejected.</a:t>
             </a:r>
           </a:p>
         </p:txBody>
@@ -1162,7 +1162,7 @@
           <a:lstStyle/>
           <a:p>
             <a:r>
-              <a:t>Delay label is defined by a finish-date threshold tau. Features are project-control signals. SVM won on ROC-AUC (0.969). Softmax/MPP adds a probabilistic reliability view.</a:t>
+              <a:t>Delay label is defined by a finish-date threshold tau. Features are project-control signals. Gradient Boosting won on ROC-AUC (0.976). Softmax/MPP adds a probabilistic reliability view.</a:t>
             </a:r>
           </a:p>
         </p:txBody>
@@ -1722,7 +1722,7 @@
           <a:lstStyle/>
           <a:p>
             <a:r>
-              <a:t>Table II: SVM best at ROC-AUC 0.969, F1 0.811. Explain why ROC-AUC/F1 matter more than raw accuracy on imbalanced delay data.</a:t>
+              <a:t>Table II: Gradient Boosting best at ROC-AUC 0.976; calibrated SVM best F1 0.784. Explain why ROC-AUC/F1 matter more than raw accuracy on imbalanced delay data.</a:t>
             </a:r>
           </a:p>
         </p:txBody>
@@ -6122,13 +6122,48 @@
       </p:sp>
       <p:sp>
         <p:nvSpPr>
-          <p:cNvPr id="15" name="Rounded Rectangle 14"/>
+          <p:cNvPr id="15" name="TextBox 14"/>
+          <p:cNvSpPr txBox="1"/>
+          <p:nvPr/>
+        </p:nvSpPr>
+        <p:spPr>
+          <a:xfrm>
+            <a:off x="822960" y="5376672"/>
+            <a:ext cx="10607040" cy="292608"/>
+          </a:xfrm>
+          <a:prstGeom prst="rect">
+            <a:avLst/>
+          </a:prstGeom>
+          <a:noFill/>
+        </p:spPr>
+        <p:txBody>
+          <a:bodyPr wrap="square" anchor="t" lIns="0" rIns="0" tIns="0" bIns="0">
+            <a:spAutoFit/>
+          </a:bodyPr>
+          <a:lstStyle/>
+          <a:p>
+            <a:pPr algn="l"/>
+            <a:r>
+              <a:rPr sz="1100" b="1" i="0">
+                <a:solidFill>
+                  <a:srgbClr val="FFFFFF"/>
+                </a:solidFill>
+                <a:latin typeface="Calibri"/>
+              </a:rPr>
+              <a:t>Guide: Dr. Manikandan K  ·  Professor Grade 2, Department of Database Systems, SCSE</a:t>
+            </a:r>
+          </a:p>
+        </p:txBody>
+      </p:sp>
+      <p:sp>
+        <p:nvSpPr>
+          <p:cNvPr id="16" name="Rounded Rectangle 15"/>
           <p:cNvSpPr/>
           <p:nvPr/>
         </p:nvSpPr>
         <p:spPr>
           <a:xfrm>
-            <a:off x="822960" y="5623560"/>
+            <a:off x="822960" y="5779008"/>
             <a:ext cx="928116" cy="365760"/>
           </a:xfrm>
           <a:prstGeom prst="roundRect">
@@ -6179,13 +6214,13 @@
       </p:sp>
       <p:sp>
         <p:nvSpPr>
-          <p:cNvPr id="16" name="Rounded Rectangle 15"/>
+          <p:cNvPr id="17" name="Rounded Rectangle 16"/>
           <p:cNvSpPr/>
           <p:nvPr/>
         </p:nvSpPr>
         <p:spPr>
           <a:xfrm>
-            <a:off x="1888236" y="5623560"/>
+            <a:off x="1888236" y="5779008"/>
             <a:ext cx="1216152" cy="365760"/>
           </a:xfrm>
           <a:prstGeom prst="roundRect">
@@ -6236,13 +6271,13 @@
       </p:sp>
       <p:sp>
         <p:nvSpPr>
-          <p:cNvPr id="17" name="Rounded Rectangle 16"/>
+          <p:cNvPr id="18" name="Rounded Rectangle 17"/>
           <p:cNvSpPr/>
           <p:nvPr/>
         </p:nvSpPr>
         <p:spPr>
           <a:xfrm>
-            <a:off x="3241548" y="5623560"/>
+            <a:off x="3241548" y="5779008"/>
             <a:ext cx="1408176" cy="365760"/>
           </a:xfrm>
           <a:prstGeom prst="roundRect">
@@ -6293,13 +6328,13 @@
       </p:sp>
       <p:sp>
         <p:nvSpPr>
-          <p:cNvPr id="18" name="Rounded Rectangle 17"/>
+          <p:cNvPr id="19" name="Rounded Rectangle 18"/>
           <p:cNvSpPr/>
           <p:nvPr/>
         </p:nvSpPr>
         <p:spPr>
           <a:xfrm>
-            <a:off x="4786883" y="5623560"/>
+            <a:off x="4786883" y="5779008"/>
             <a:ext cx="1024128" cy="365760"/>
           </a:xfrm>
           <a:prstGeom prst="roundRect">
@@ -6350,13 +6385,13 @@
       </p:sp>
       <p:sp>
         <p:nvSpPr>
-          <p:cNvPr id="19" name="Rounded Rectangle 18"/>
+          <p:cNvPr id="20" name="Rounded Rectangle 19"/>
           <p:cNvSpPr/>
           <p:nvPr/>
         </p:nvSpPr>
         <p:spPr>
           <a:xfrm>
-            <a:off x="5948171" y="5623560"/>
+            <a:off x="5948171" y="5779008"/>
             <a:ext cx="832104" cy="365760"/>
           </a:xfrm>
           <a:prstGeom prst="roundRect">
@@ -6407,13 +6442,13 @@
       </p:sp>
       <p:sp>
         <p:nvSpPr>
-          <p:cNvPr id="20" name="Rounded Rectangle 19"/>
+          <p:cNvPr id="21" name="Rounded Rectangle 20"/>
           <p:cNvSpPr/>
           <p:nvPr/>
         </p:nvSpPr>
         <p:spPr>
           <a:xfrm>
-            <a:off x="6917436" y="5623560"/>
+            <a:off x="6917436" y="5779008"/>
             <a:ext cx="1216152" cy="365760"/>
           </a:xfrm>
           <a:prstGeom prst="roundRect">
@@ -11057,7 +11092,7 @@
                 </a:solidFill>
                 <a:latin typeface="Calibri"/>
               </a:rPr>
-              <a:t>19,317 records ingested — 0 rejected in the verified run</a:t>
+              <a:t>13,980 records ingested — 0 rejected in the verified run</a:t>
             </a:r>
           </a:p>
         </p:txBody>
@@ -13042,7 +13077,7 @@
                           </a:solidFill>
                           <a:latin typeface="Calibri"/>
                         </a:rPr>
-                        <a:t>0.880</a:t>
+                        <a:t>0.900</a:t>
                       </a:r>
                     </a:p>
                   </a:txBody>
@@ -13064,7 +13099,7 @@
                           </a:solidFill>
                           <a:latin typeface="Calibri"/>
                         </a:rPr>
-                        <a:t>0.704</a:t>
+                        <a:t>0.700</a:t>
                       </a:r>
                     </a:p>
                   </a:txBody>
@@ -13086,7 +13121,7 @@
                           </a:solidFill>
                           <a:latin typeface="Calibri"/>
                         </a:rPr>
-                        <a:t>0.805</a:t>
+                        <a:t>0.856</a:t>
                       </a:r>
                     </a:p>
                   </a:txBody>
@@ -13108,7 +13143,7 @@
                           </a:solidFill>
                           <a:latin typeface="Calibri"/>
                         </a:rPr>
-                        <a:t>0.746</a:t>
+                        <a:t>0.763</a:t>
                       </a:r>
                     </a:p>
                   </a:txBody>
@@ -13130,7 +13165,7 @@
                           </a:solidFill>
                           <a:latin typeface="Calibri"/>
                         </a:rPr>
-                        <a:t>0.955</a:t>
+                        <a:t>0.960</a:t>
                       </a:r>
                     </a:p>
                   </a:txBody>
@@ -13154,7 +13189,7 @@
                           </a:solidFill>
                           <a:latin typeface="Calibri"/>
                         </a:rPr>
-                        <a:t>Gradient Boosting</a:t>
+                        <a:t>Gradient Boosting (selected)</a:t>
                       </a:r>
                     </a:p>
                   </a:txBody>
@@ -13176,7 +13211,7 @@
                           </a:solidFill>
                           <a:latin typeface="Calibri"/>
                         </a:rPr>
-                        <a:t>0.903</a:t>
+                        <a:t>0.913</a:t>
                       </a:r>
                     </a:p>
                   </a:txBody>
@@ -13198,7 +13233,7 @@
                           </a:solidFill>
                           <a:latin typeface="Calibri"/>
                         </a:rPr>
-                        <a:t>0.820</a:t>
+                        <a:t>0.789</a:t>
                       </a:r>
                     </a:p>
                   </a:txBody>
@@ -13220,7 +13255,7 @@
                           </a:solidFill>
                           <a:latin typeface="Calibri"/>
                         </a:rPr>
-                        <a:t>0.713</a:t>
+                        <a:t>0.730</a:t>
                       </a:r>
                     </a:p>
                   </a:txBody>
@@ -13242,7 +13277,7 @@
                           </a:solidFill>
                           <a:latin typeface="Calibri"/>
                         </a:rPr>
-                        <a:t>0.762</a:t>
+                        <a:t>0.748</a:t>
                       </a:r>
                     </a:p>
                   </a:txBody>
@@ -13264,7 +13299,7 @@
                           </a:solidFill>
                           <a:latin typeface="Calibri"/>
                         </a:rPr>
-                        <a:t>0.943</a:t>
+                        <a:t>0.976</a:t>
                       </a:r>
                     </a:p>
                   </a:txBody>
@@ -13288,7 +13323,7 @@
                           </a:solidFill>
                           <a:latin typeface="Calibri"/>
                         </a:rPr>
-                        <a:t>SVM (selected)</a:t>
+                        <a:t>Calibrated SVM</a:t>
                       </a:r>
                     </a:p>
                   </a:txBody>
@@ -13332,7 +13367,7 @@
                           </a:solidFill>
                           <a:latin typeface="Calibri"/>
                         </a:rPr>
-                        <a:t>0.849</a:t>
+                        <a:t>0.799</a:t>
                       </a:r>
                     </a:p>
                   </a:txBody>
@@ -13354,7 +13389,7 @@
                           </a:solidFill>
                           <a:latin typeface="Calibri"/>
                         </a:rPr>
-                        <a:t>0.791</a:t>
+                        <a:t>0.785</a:t>
                       </a:r>
                     </a:p>
                   </a:txBody>
@@ -13376,7 +13411,7 @@
                           </a:solidFill>
                           <a:latin typeface="Calibri"/>
                         </a:rPr>
-                        <a:t>0.811</a:t>
+                        <a:t>0.784</a:t>
                       </a:r>
                     </a:p>
                   </a:txBody>
@@ -13398,7 +13433,7 @@
                           </a:solidFill>
                           <a:latin typeface="Calibri"/>
                         </a:rPr>
-                        <a:t>0.969</a:t>
+                        <a:t>0.949</a:t>
                       </a:r>
                     </a:p>
                   </a:txBody>
@@ -19491,7 +19526,7 @@
                           </a:solidFill>
                           <a:latin typeface="Calibri"/>
                         </a:rPr>
-                        <a:t>0.880</a:t>
+                        <a:t>0.900</a:t>
                       </a:r>
                     </a:p>
                   </a:txBody>
@@ -19513,7 +19548,7 @@
                           </a:solidFill>
                           <a:latin typeface="Calibri"/>
                         </a:rPr>
-                        <a:t>0.704</a:t>
+                        <a:t>0.700</a:t>
                       </a:r>
                     </a:p>
                   </a:txBody>
@@ -19535,7 +19570,7 @@
                           </a:solidFill>
                           <a:latin typeface="Calibri"/>
                         </a:rPr>
-                        <a:t>0.805</a:t>
+                        <a:t>0.856</a:t>
                       </a:r>
                     </a:p>
                   </a:txBody>
@@ -19557,7 +19592,7 @@
                           </a:solidFill>
                           <a:latin typeface="Calibri"/>
                         </a:rPr>
-                        <a:t>0.746</a:t>
+                        <a:t>0.763</a:t>
                       </a:r>
                     </a:p>
                   </a:txBody>
@@ -19579,7 +19614,7 @@
                           </a:solidFill>
                           <a:latin typeface="Calibri"/>
                         </a:rPr>
-                        <a:t>0.955</a:t>
+                        <a:t>0.960</a:t>
                       </a:r>
                     </a:p>
                   </a:txBody>
@@ -19603,7 +19638,7 @@
                           </a:solidFill>
                           <a:latin typeface="Calibri"/>
                         </a:rPr>
-                        <a:t>Gradient Boosting</a:t>
+                        <a:t>Gradient Boosting (selected)</a:t>
                       </a:r>
                     </a:p>
                   </a:txBody>
@@ -19625,7 +19660,7 @@
                           </a:solidFill>
                           <a:latin typeface="Calibri"/>
                         </a:rPr>
-                        <a:t>0.903</a:t>
+                        <a:t>0.913</a:t>
                       </a:r>
                     </a:p>
                   </a:txBody>
@@ -19647,7 +19682,7 @@
                           </a:solidFill>
                           <a:latin typeface="Calibri"/>
                         </a:rPr>
-                        <a:t>0.820</a:t>
+                        <a:t>0.789</a:t>
                       </a:r>
                     </a:p>
                   </a:txBody>
@@ -19669,7 +19704,7 @@
                           </a:solidFill>
                           <a:latin typeface="Calibri"/>
                         </a:rPr>
-                        <a:t>0.713</a:t>
+                        <a:t>0.730</a:t>
                       </a:r>
                     </a:p>
                   </a:txBody>
@@ -19691,7 +19726,7 @@
                           </a:solidFill>
                           <a:latin typeface="Calibri"/>
                         </a:rPr>
-                        <a:t>0.762</a:t>
+                        <a:t>0.748</a:t>
                       </a:r>
                     </a:p>
                   </a:txBody>
@@ -19713,7 +19748,7 @@
                           </a:solidFill>
                           <a:latin typeface="Calibri"/>
                         </a:rPr>
-                        <a:t>0.943</a:t>
+                        <a:t>0.976</a:t>
                       </a:r>
                     </a:p>
                   </a:txBody>
@@ -19737,7 +19772,7 @@
                           </a:solidFill>
                           <a:latin typeface="Calibri"/>
                         </a:rPr>
-                        <a:t>SVM (selected)</a:t>
+                        <a:t>Calibrated SVM</a:t>
                       </a:r>
                     </a:p>
                   </a:txBody>
@@ -19781,7 +19816,7 @@
                           </a:solidFill>
                           <a:latin typeface="Calibri"/>
                         </a:rPr>
-                        <a:t>0.849</a:t>
+                        <a:t>0.799</a:t>
                       </a:r>
                     </a:p>
                   </a:txBody>
@@ -19803,7 +19838,7 @@
                           </a:solidFill>
                           <a:latin typeface="Calibri"/>
                         </a:rPr>
-                        <a:t>0.791</a:t>
+                        <a:t>0.785</a:t>
                       </a:r>
                     </a:p>
                   </a:txBody>
@@ -19825,7 +19860,7 @@
                           </a:solidFill>
                           <a:latin typeface="Calibri"/>
                         </a:rPr>
-                        <a:t>0.811</a:t>
+                        <a:t>0.784</a:t>
                       </a:r>
                     </a:p>
                   </a:txBody>
@@ -19847,7 +19882,7 @@
                           </a:solidFill>
                           <a:latin typeface="Calibri"/>
                         </a:rPr>
-                        <a:t>0.969</a:t>
+                        <a:t>0.949</a:t>
                       </a:r>
                     </a:p>
                   </a:txBody>
@@ -19892,7 +19927,7 @@
                 </a:solidFill>
                 <a:latin typeface="Calibri"/>
               </a:rPr>
-              <a:t>SVM selected by highest ROC-AUC (0.969).</a:t>
+              <a:t>Gradient Boosting selected by highest ROC-AUC (0.976).</a:t>
             </a:r>
           </a:p>
         </p:txBody>
@@ -20030,7 +20065,7 @@
                 </a:solidFill>
                 <a:latin typeface="Calibri"/>
               </a:rPr>
-              <a:t>•  ROC-AUC 0.969 means strong separation of delayed vs. on-time activities.</a:t>
+              <a:t>•  ROC-AUC 0.976 means strong separation of delayed vs. on-time activities.</a:t>
             </a:r>
           </a:p>
           <a:p>
@@ -20046,7 +20081,7 @@
                 </a:solidFill>
                 <a:latin typeface="Calibri"/>
               </a:rPr>
-              <a:t>•  F1 0.811 balances precision and recall for actionable alerts.</a:t>
+              <a:t>•  F1 0.784 balances precision and recall for actionable alerts.</a:t>
             </a:r>
           </a:p>
           <a:p>
@@ -21257,7 +21292,7 @@
                 </a:solidFill>
                 <a:latin typeface="Calibri"/>
               </a:rPr>
-              <a:t>19,317 records ingested, 0 rejected; malformed payloads return HTTP 422</a:t>
+              <a:t>13,980 records ingested, 0 rejected; malformed payloads return HTTP 422</a:t>
             </a:r>
           </a:p>
         </p:txBody>
@@ -23179,7 +23214,7 @@
                 </a:solidFill>
                 <a:latin typeface="Calibri"/>
               </a:rPr>
-              <a:t>•  Calibrated SVM achieving 0.969 ROC-AUC on delay prediction.</a:t>
+              <a:t>•  Gradient Boosting achieving 0.976 ROC-AUC on delay prediction.</a:t>
             </a:r>
           </a:p>
           <a:p>
@@ -24704,7 +24739,7 @@
                 </a:solidFill>
                 <a:latin typeface="Calibri"/>
               </a:rPr>
-              <a:t>OVERVIEW</a:t>
+              <a:t>02 — OVERVIEW</a:t>
             </a:r>
           </a:p>
         </p:txBody>
@@ -25470,7 +25505,7 @@
                 </a:solidFill>
                 <a:latin typeface="Calibri"/>
               </a:rPr>
-              <a:t>OVERVIEW</a:t>
+              <a:t>02 — OVERVIEW</a:t>
             </a:r>
           </a:p>
         </p:txBody>
@@ -27080,7 +27115,7 @@
                 </a:solidFill>
                 <a:latin typeface="Calibri"/>
               </a:rPr>
-              <a:t>OVERVIEW</a:t>
+              <a:t>02 — OVERVIEW</a:t>
             </a:r>
           </a:p>
         </p:txBody>

</xml_diff>